<commit_message>
docs(pitch): actualizar notas de orador y script de despliegue en pages
</commit_message>
<xml_diff>
--- a/docs/pitch/Amauti_Pitch.pptx
+++ b/docs/pitch/Amauti_Pitch.pptx
@@ -683,7 +683,7 @@
           <a:p>
             <a:r>
               <a:rPr lang="en-US" dirty="0"/>
-              <a:t>0:44-1:08 Augusto. Amauti cierra el ciclo señal -&gt; rescate. Tres pilares. Pase a Xander.</a:t>
+              <a:t>0:44-1:08 Augusto. Con un mensaje o audio de 10s en WhatsApp, el docente registra avances en 1° A validados contra su lista oficial y detona en el acto la alerta temprana por las 4 faltas de Nayeli Cachique. Pase a Xander para ver cómo se atiende el caso de Nayeli en la web.</a:t>
             </a:r>
             <a:endParaRPr lang="en-US" dirty="0"/>
           </a:p>
@@ -771,7 +771,7 @@
           <a:p>
             <a:r>
               <a:rPr lang="en-US" dirty="0"/>
-              <a:t>1:08-2:10 Xander. Web en vivo. 1) Hoy/Alertas: 5 alumnos, plazo 48h. 2) Atender caso (Nayeli): bitácora, mensaje a familia, plan de apoyo cifrado. 3) Panorama/Reportes sin Excel extra.</a:t>
+              <a:t>1:08-2:10 Xander. Web en vivo. 1) Hoy/Alertas: la alerta de Nayeli que nació en WhatsApp ya está aquí con plazo de 48h. 2) Atender caso (Nayeli): bitácora, mensaje a familia, plan de apoyo cifrado. 3) Panorama/Reportes sin Excel extra.</a:t>
             </a:r>
             <a:endParaRPr lang="en-US" dirty="0"/>
           </a:p>
@@ -1462,7 +1462,7 @@
         </p:nvSpPr>
         <p:spPr>
           <a:xfrm>
-            <a:off x="548640" y="6309360"/>
+            <a:off x="548640" y="6355080"/>
             <a:ext cx="5486400" cy="320040"/>
           </a:xfrm>
           <a:prstGeom prst="rect">
@@ -2118,7 +2118,7 @@
         </p:nvSpPr>
         <p:spPr>
           <a:xfrm>
-            <a:off x="548640" y="6309360"/>
+            <a:off x="548640" y="6355080"/>
             <a:ext cx="5486400" cy="320040"/>
           </a:xfrm>
           <a:prstGeom prst="rect">
@@ -2163,7 +2163,7 @@
     <p:bg>
       <p:bgPr>
         <a:solidFill>
-          <a:srgbClr val="FFFFFF"/>
+          <a:srgbClr val="F5F7FA"/>
         </a:solidFill>
       </p:bgPr>
     </p:bg>
@@ -2189,8 +2189,8 @@
         </p:nvSpPr>
         <p:spPr>
           <a:xfrm>
-            <a:off x="548640" y="457200"/>
-            <a:ext cx="10972800" cy="822960"/>
+            <a:off x="548640" y="365760"/>
+            <a:ext cx="11064240" cy="640080"/>
           </a:xfrm>
           <a:prstGeom prst="rect">
             <a:avLst/>
@@ -2206,7 +2206,7 @@
               <a:buNone/>
             </a:pPr>
             <a:r>
-              <a:rPr lang="en-US" sz="4000" b="1" dirty="0">
+              <a:rPr lang="en-US" sz="3600" b="1" dirty="0">
                 <a:solidFill>
                   <a:srgbClr val="003876"/>
                 </a:solidFill>
@@ -2214,9 +2214,9 @@
                 <a:ea typeface="Calibri" pitchFamily="34" charset="-122"/>
                 <a:cs typeface="Calibri" pitchFamily="34" charset="-120"/>
               </a:rPr>
-              <a:t>Del audio de 10 s al rescate</a:t>
-            </a:r>
-            <a:endParaRPr lang="en-US" sz="4000" dirty="0"/>
+              <a:t>La diferencia Amauti: del aula al rescate en 10 s</a:t>
+            </a:r>
+            <a:endParaRPr lang="en-US" sz="3600" dirty="0"/>
           </a:p>
         </p:txBody>
       </p:sp>
@@ -2228,13 +2228,140 @@
         </p:nvSpPr>
         <p:spPr>
           <a:xfrm>
-            <a:off x="548640" y="1828800"/>
-            <a:ext cx="2926080" cy="3291840"/>
+            <a:off x="493776" y="1133856"/>
+            <a:ext cx="2304288" cy="4965192"/>
           </a:xfrm>
           <a:prstGeom prst="roundRect">
             <a:avLst>
-              <a:gd name="adj" fmla="val 6250"/>
+              <a:gd name="adj" fmla="val 4762"/>
             </a:avLst>
+          </a:prstGeom>
+          <a:solidFill>
+            <a:srgbClr val="1A2332"/>
+          </a:solidFill>
+          <a:ln w="12700">
+            <a:solidFill>
+              <a:srgbClr val="1A2332"/>
+            </a:solidFill>
+            <a:prstDash val="solid"/>
+          </a:ln>
+        </p:spPr>
+      </p:sp>
+      <p:pic>
+        <p:nvPicPr>
+          <p:cNvPr id="4" name="Image 0" descr="D:\Augusto\personal_portfolio\hacktheandes-educacion\docs\pitch\assets\wa-bitacora.png">    </p:cNvPr>
+          <p:cNvPicPr>
+            <a:picLocks noChangeAspect="1"/>
+          </p:cNvPicPr>
+          <p:nvPr/>
+        </p:nvPicPr>
+        <p:blipFill>
+          <a:blip r:embed="rId1"/>
+          <a:stretch>
+            <a:fillRect/>
+          </a:stretch>
+        </p:blipFill>
+        <p:spPr>
+          <a:xfrm>
+            <a:off x="548640" y="1188720"/>
+            <a:ext cx="2194560" cy="4855464"/>
+          </a:xfrm>
+          <a:prstGeom prst="rect">
+            <a:avLst/>
+          </a:prstGeom>
+        </p:spPr>
+      </p:pic>
+      <p:sp>
+        <p:nvSpPr>
+          <p:cNvPr id="5" name="Shape 2"/>
+          <p:cNvSpPr/>
+          <p:nvPr/>
+        </p:nvSpPr>
+        <p:spPr>
+          <a:xfrm>
+            <a:off x="2962656" y="1133856"/>
+            <a:ext cx="2304288" cy="4965192"/>
+          </a:xfrm>
+          <a:prstGeom prst="roundRect">
+            <a:avLst>
+              <a:gd name="adj" fmla="val 4762"/>
+            </a:avLst>
+          </a:prstGeom>
+          <a:solidFill>
+            <a:srgbClr val="1A2332"/>
+          </a:solidFill>
+          <a:ln w="12700">
+            <a:solidFill>
+              <a:srgbClr val="1A2332"/>
+            </a:solidFill>
+            <a:prstDash val="solid"/>
+          </a:ln>
+        </p:spPr>
+      </p:sp>
+      <p:pic>
+        <p:nvPicPr>
+          <p:cNvPr id="6" name="Image 1" descr="D:\Augusto\personal_portfolio\hacktheandes-educacion\docs\pitch\assets\wa-alerta.png">    </p:cNvPr>
+          <p:cNvPicPr>
+            <a:picLocks noChangeAspect="1"/>
+          </p:cNvPicPr>
+          <p:nvPr/>
+        </p:nvPicPr>
+        <p:blipFill>
+          <a:blip r:embed="rId2"/>
+          <a:stretch>
+            <a:fillRect/>
+          </a:stretch>
+        </p:blipFill>
+        <p:spPr>
+          <a:xfrm>
+            <a:off x="3017520" y="1188720"/>
+            <a:ext cx="2194560" cy="4855464"/>
+          </a:xfrm>
+          <a:prstGeom prst="rect">
+            <a:avLst/>
+          </a:prstGeom>
+        </p:spPr>
+      </p:pic>
+      <p:sp>
+        <p:nvSpPr>
+          <p:cNvPr id="7" name="Shape 3"/>
+          <p:cNvSpPr/>
+          <p:nvPr/>
+        </p:nvSpPr>
+        <p:spPr>
+          <a:xfrm>
+            <a:off x="5577840" y="1188720"/>
+            <a:ext cx="6035040" cy="1463040"/>
+          </a:xfrm>
+          <a:prstGeom prst="roundRect">
+            <a:avLst>
+              <a:gd name="adj" fmla="val 9375"/>
+            </a:avLst>
+          </a:prstGeom>
+          <a:solidFill>
+            <a:srgbClr val="FFFFFF"/>
+          </a:solidFill>
+          <a:ln w="12700">
+            <a:solidFill>
+              <a:srgbClr val="E1E5EB"/>
+            </a:solidFill>
+            <a:prstDash val="solid"/>
+          </a:ln>
+        </p:spPr>
+      </p:sp>
+      <p:sp>
+        <p:nvSpPr>
+          <p:cNvPr id="8" name="Shape 4"/>
+          <p:cNvSpPr/>
+          <p:nvPr/>
+        </p:nvSpPr>
+        <p:spPr>
+          <a:xfrm>
+            <a:off x="5852160" y="1600200"/>
+            <a:ext cx="640080" cy="640080"/>
+          </a:xfrm>
+          <a:prstGeom prst="ellipse">
+            <a:avLst/>
           </a:prstGeom>
           <a:solidFill>
             <a:srgbClr val="2B8A3E"/>
@@ -2249,14 +2376,14 @@
       </p:sp>
       <p:sp>
         <p:nvSpPr>
-          <p:cNvPr id="4" name="Text 2"/>
-          <p:cNvSpPr/>
-          <p:nvPr/>
-        </p:nvSpPr>
-        <p:spPr>
-          <a:xfrm>
-            <a:off x="548640" y="2194560"/>
-            <a:ext cx="2926080" cy="1463040"/>
+          <p:cNvPr id="9" name="Text 5"/>
+          <p:cNvSpPr/>
+          <p:nvPr/>
+        </p:nvSpPr>
+        <p:spPr>
+          <a:xfrm>
+            <a:off x="5852160" y="1600200"/>
+            <a:ext cx="640080" cy="640080"/>
           </a:xfrm>
           <a:prstGeom prst="rect">
             <a:avLst/>
@@ -2272,7 +2399,7 @@
               <a:buNone/>
             </a:pPr>
             <a:r>
-              <a:rPr lang="en-US" sz="8000" b="1" dirty="0">
+              <a:rPr lang="en-US" sz="2400" b="1" dirty="0">
                 <a:solidFill>
                   <a:srgbClr val="FFFFFF"/>
                 </a:solidFill>
@@ -2280,94 +2407,77 @@
                 <a:ea typeface="Calibri" pitchFamily="34" charset="-122"/>
                 <a:cs typeface="Calibri" pitchFamily="34" charset="-120"/>
               </a:rPr>
-              <a:t>10 s</a:t>
-            </a:r>
-            <a:endParaRPr lang="en-US" sz="8000" dirty="0"/>
-          </a:p>
-        </p:txBody>
-      </p:sp>
-      <p:sp>
-        <p:nvSpPr>
-          <p:cNvPr id="5" name="Text 3"/>
-          <p:cNvSpPr/>
-          <p:nvPr/>
-        </p:nvSpPr>
-        <p:spPr>
-          <a:xfrm>
-            <a:off x="548640" y="3657600"/>
-            <a:ext cx="2926080" cy="1097280"/>
-          </a:xfrm>
-          <a:prstGeom prst="rect">
-            <a:avLst/>
-          </a:prstGeom>
-          <a:noFill/>
-          <a:ln/>
-        </p:spPr>
-        <p:txBody>
-          <a:bodyPr wrap="square" lIns="0" tIns="0" rIns="0" bIns="0" rtlCol="0" anchor="ctr"/>
-          <a:lstStyle/>
-          <a:p>
-            <a:pPr algn="ctr" indent="0" marL="0">
-              <a:buNone/>
-            </a:pPr>
-            <a:r>
-              <a:rPr lang="en-US" sz="2600" dirty="0">
-                <a:solidFill>
-                  <a:srgbClr val="FFFFFF"/>
-                </a:solidFill>
-                <a:latin typeface="Calibri" pitchFamily="34" charset="0"/>
-                <a:ea typeface="Calibri" pitchFamily="34" charset="-122"/>
-                <a:cs typeface="Calibri" pitchFamily="34" charset="-120"/>
-              </a:rPr>
-              <a:t>audio en</a:t>
+              <a:t>1</a:t>
+            </a:r>
+            <a:endParaRPr lang="en-US" sz="2400" dirty="0"/>
+          </a:p>
+        </p:txBody>
+      </p:sp>
+      <p:sp>
+        <p:nvSpPr>
+          <p:cNvPr id="10" name="Text 6"/>
+          <p:cNvSpPr/>
+          <p:nvPr/>
+        </p:nvSpPr>
+        <p:spPr>
+          <a:xfrm>
+            <a:off x="6720840" y="1371600"/>
+            <a:ext cx="4663440" cy="502920"/>
+          </a:xfrm>
+          <a:prstGeom prst="rect">
+            <a:avLst/>
+          </a:prstGeom>
+          <a:noFill/>
+          <a:ln/>
+        </p:spPr>
+        <p:txBody>
+          <a:bodyPr wrap="square" lIns="0" tIns="0" rIns="0" bIns="0" rtlCol="0" anchor="ctr"/>
+          <a:lstStyle/>
+          <a:p>
+            <a:pPr indent="0" marL="0">
+              <a:buNone/>
+            </a:pPr>
+            <a:r>
+              <a:rPr lang="en-US" sz="2600" b="1" dirty="0">
+                <a:solidFill>
+                  <a:srgbClr val="1A2332"/>
+                </a:solidFill>
+                <a:latin typeface="Calibri" pitchFamily="34" charset="0"/>
+                <a:ea typeface="Calibri" pitchFamily="34" charset="-122"/>
+                <a:cs typeface="Calibri" pitchFamily="34" charset="-120"/>
+              </a:rPr>
+              <a:t>Bitácora validada</a:t>
             </a:r>
             <a:endParaRPr lang="en-US" sz="2600" dirty="0"/>
           </a:p>
-          <a:p>
-            <a:pPr algn="ctr" indent="0" marL="0">
-              <a:buNone/>
-            </a:pPr>
-            <a:r>
-              <a:rPr lang="en-US" sz="2600" dirty="0">
-                <a:solidFill>
-                  <a:srgbClr val="FFFFFF"/>
-                </a:solidFill>
-                <a:latin typeface="Calibri" pitchFamily="34" charset="0"/>
-                <a:ea typeface="Calibri" pitchFamily="34" charset="-122"/>
-                <a:cs typeface="Calibri" pitchFamily="34" charset="-120"/>
-              </a:rPr>
-              <a:t>WhatsApp</a:t>
-            </a:r>
-            <a:endParaRPr lang="en-US" sz="2600" dirty="0"/>
-          </a:p>
-        </p:txBody>
-      </p:sp>
-      <p:sp>
-        <p:nvSpPr>
-          <p:cNvPr id="6" name="Text 4"/>
-          <p:cNvSpPr/>
-          <p:nvPr/>
-        </p:nvSpPr>
-        <p:spPr>
-          <a:xfrm>
-            <a:off x="3520440" y="3017520"/>
-            <a:ext cx="731520" cy="731520"/>
-          </a:xfrm>
-          <a:prstGeom prst="rect">
-            <a:avLst/>
-          </a:prstGeom>
-          <a:noFill/>
-          <a:ln/>
-        </p:spPr>
-        <p:txBody>
-          <a:bodyPr wrap="square" lIns="0" tIns="0" rIns="0" bIns="0" rtlCol="0" anchor="ctr"/>
-          <a:lstStyle/>
-          <a:p>
-            <a:pPr algn="ctr" indent="0" marL="0">
-              <a:buNone/>
-            </a:pPr>
-            <a:r>
-              <a:rPr lang="en-US" sz="4400" b="1" dirty="0">
+        </p:txBody>
+      </p:sp>
+      <p:sp>
+        <p:nvSpPr>
+          <p:cNvPr id="11" name="Text 7"/>
+          <p:cNvSpPr/>
+          <p:nvPr/>
+        </p:nvSpPr>
+        <p:spPr>
+          <a:xfrm>
+            <a:off x="6720840" y="1901952"/>
+            <a:ext cx="4663440" cy="594360"/>
+          </a:xfrm>
+          <a:prstGeom prst="rect">
+            <a:avLst/>
+          </a:prstGeom>
+          <a:noFill/>
+          <a:ln/>
+        </p:spPr>
+        <p:txBody>
+          <a:bodyPr wrap="square" lIns="0" tIns="0" rIns="0" bIns="0" rtlCol="0" anchor="ctr"/>
+          <a:lstStyle/>
+          <a:p>
+            <a:pPr indent="0" marL="0">
+              <a:buNone/>
+            </a:pPr>
+            <a:r>
+              <a:rPr lang="en-US" sz="1800" dirty="0">
                 <a:solidFill>
                   <a:srgbClr val="5A6578"/>
                 </a:solidFill>
@@ -2375,26 +2485,195 @@
                 <a:ea typeface="Calibri" pitchFamily="34" charset="-122"/>
                 <a:cs typeface="Calibri" pitchFamily="34" charset="-120"/>
               </a:rPr>
-              <a:t>➔</a:t>
-            </a:r>
-            <a:endParaRPr lang="en-US" sz="4400" dirty="0"/>
-          </a:p>
-        </p:txBody>
-      </p:sp>
-      <p:sp>
-        <p:nvSpPr>
-          <p:cNvPr id="7" name="Shape 5"/>
-          <p:cNvSpPr/>
-          <p:nvPr/>
-        </p:nvSpPr>
-        <p:spPr>
-          <a:xfrm>
-            <a:off x="4343400" y="1828800"/>
-            <a:ext cx="2286000" cy="3291840"/>
+              <a:t>Registra avances (Lucero, Huamán) y valida la lista oficial de 1° A</a:t>
+            </a:r>
+            <a:endParaRPr lang="en-US" sz="1800" dirty="0"/>
+          </a:p>
+        </p:txBody>
+      </p:sp>
+      <p:sp>
+        <p:nvSpPr>
+          <p:cNvPr id="12" name="Shape 8"/>
+          <p:cNvSpPr/>
+          <p:nvPr/>
+        </p:nvSpPr>
+        <p:spPr>
+          <a:xfrm>
+            <a:off x="5577840" y="2880360"/>
+            <a:ext cx="6035040" cy="1463040"/>
           </a:xfrm>
           <a:prstGeom prst="roundRect">
             <a:avLst>
-              <a:gd name="adj" fmla="val 8000"/>
+              <a:gd name="adj" fmla="val 9375"/>
+            </a:avLst>
+          </a:prstGeom>
+          <a:solidFill>
+            <a:srgbClr val="FFEEF0"/>
+          </a:solidFill>
+          <a:ln w="12700">
+            <a:solidFill>
+              <a:srgbClr val="E1E5EB"/>
+            </a:solidFill>
+            <a:prstDash val="solid"/>
+          </a:ln>
+        </p:spPr>
+      </p:sp>
+      <p:sp>
+        <p:nvSpPr>
+          <p:cNvPr id="13" name="Shape 9"/>
+          <p:cNvSpPr/>
+          <p:nvPr/>
+        </p:nvSpPr>
+        <p:spPr>
+          <a:xfrm>
+            <a:off x="5852160" y="3291840"/>
+            <a:ext cx="640080" cy="640080"/>
+          </a:xfrm>
+          <a:prstGeom prst="ellipse">
+            <a:avLst/>
+          </a:prstGeom>
+          <a:solidFill>
+            <a:srgbClr val="C8102E"/>
+          </a:solidFill>
+          <a:ln w="12700">
+            <a:solidFill>
+              <a:srgbClr val="C8102E"/>
+            </a:solidFill>
+            <a:prstDash val="solid"/>
+          </a:ln>
+        </p:spPr>
+      </p:sp>
+      <p:sp>
+        <p:nvSpPr>
+          <p:cNvPr id="14" name="Text 10"/>
+          <p:cNvSpPr/>
+          <p:nvPr/>
+        </p:nvSpPr>
+        <p:spPr>
+          <a:xfrm>
+            <a:off x="5852160" y="3291840"/>
+            <a:ext cx="640080" cy="640080"/>
+          </a:xfrm>
+          <a:prstGeom prst="rect">
+            <a:avLst/>
+          </a:prstGeom>
+          <a:noFill/>
+          <a:ln/>
+        </p:spPr>
+        <p:txBody>
+          <a:bodyPr wrap="square" lIns="0" tIns="0" rIns="0" bIns="0" rtlCol="0" anchor="ctr"/>
+          <a:lstStyle/>
+          <a:p>
+            <a:pPr algn="ctr" indent="0" marL="0">
+              <a:buNone/>
+            </a:pPr>
+            <a:r>
+              <a:rPr lang="en-US" sz="2400" b="1" dirty="0">
+                <a:solidFill>
+                  <a:srgbClr val="FFFFFF"/>
+                </a:solidFill>
+                <a:latin typeface="Calibri" pitchFamily="34" charset="0"/>
+                <a:ea typeface="Calibri" pitchFamily="34" charset="-122"/>
+                <a:cs typeface="Calibri" pitchFamily="34" charset="-120"/>
+              </a:rPr>
+              <a:t>2</a:t>
+            </a:r>
+            <a:endParaRPr lang="en-US" sz="2400" dirty="0"/>
+          </a:p>
+        </p:txBody>
+      </p:sp>
+      <p:sp>
+        <p:nvSpPr>
+          <p:cNvPr id="15" name="Text 11"/>
+          <p:cNvSpPr/>
+          <p:nvPr/>
+        </p:nvSpPr>
+        <p:spPr>
+          <a:xfrm>
+            <a:off x="6720840" y="3063240"/>
+            <a:ext cx="4663440" cy="502920"/>
+          </a:xfrm>
+          <a:prstGeom prst="rect">
+            <a:avLst/>
+          </a:prstGeom>
+          <a:noFill/>
+          <a:ln/>
+        </p:spPr>
+        <p:txBody>
+          <a:bodyPr wrap="square" lIns="0" tIns="0" rIns="0" bIns="0" rtlCol="0" anchor="ctr"/>
+          <a:lstStyle/>
+          <a:p>
+            <a:pPr indent="0" marL="0">
+              <a:buNone/>
+            </a:pPr>
+            <a:r>
+              <a:rPr lang="en-US" sz="2600" b="1" dirty="0">
+                <a:solidFill>
+                  <a:srgbClr val="1A2332"/>
+                </a:solidFill>
+                <a:latin typeface="Calibri" pitchFamily="34" charset="0"/>
+                <a:ea typeface="Calibri" pitchFamily="34" charset="-122"/>
+                <a:cs typeface="Calibri" pitchFamily="34" charset="-120"/>
+              </a:rPr>
+              <a:t>Alerta al instante</a:t>
+            </a:r>
+            <a:endParaRPr lang="en-US" sz="2600" dirty="0"/>
+          </a:p>
+        </p:txBody>
+      </p:sp>
+      <p:sp>
+        <p:nvSpPr>
+          <p:cNvPr id="16" name="Text 12"/>
+          <p:cNvSpPr/>
+          <p:nvPr/>
+        </p:nvSpPr>
+        <p:spPr>
+          <a:xfrm>
+            <a:off x="6720840" y="3593592"/>
+            <a:ext cx="4663440" cy="594360"/>
+          </a:xfrm>
+          <a:prstGeom prst="rect">
+            <a:avLst/>
+          </a:prstGeom>
+          <a:noFill/>
+          <a:ln/>
+        </p:spPr>
+        <p:txBody>
+          <a:bodyPr wrap="square" lIns="0" tIns="0" rIns="0" bIns="0" rtlCol="0" anchor="ctr"/>
+          <a:lstStyle/>
+          <a:p>
+            <a:pPr indent="0" marL="0">
+              <a:buNone/>
+            </a:pPr>
+            <a:r>
+              <a:rPr lang="en-US" sz="1800" dirty="0">
+                <a:solidFill>
+                  <a:srgbClr val="5A6578"/>
+                </a:solidFill>
+                <a:latin typeface="Calibri" pitchFamily="34" charset="0"/>
+                <a:ea typeface="Calibri" pitchFamily="34" charset="-122"/>
+                <a:cs typeface="Calibri" pitchFamily="34" charset="-120"/>
+              </a:rPr>
+              <a:t>4 faltas de Nayeli ➔ Abre caso de riesgo alto en el acto</a:t>
+            </a:r>
+            <a:endParaRPr lang="en-US" sz="1800" dirty="0"/>
+          </a:p>
+        </p:txBody>
+      </p:sp>
+      <p:sp>
+        <p:nvSpPr>
+          <p:cNvPr id="17" name="Shape 13"/>
+          <p:cNvSpPr/>
+          <p:nvPr/>
+        </p:nvSpPr>
+        <p:spPr>
+          <a:xfrm>
+            <a:off x="5577840" y="4572000"/>
+            <a:ext cx="6035040" cy="1463040"/>
+          </a:xfrm>
+          <a:prstGeom prst="roundRect">
+            <a:avLst>
+              <a:gd name="adj" fmla="val 9375"/>
             </a:avLst>
           </a:prstGeom>
           <a:solidFill>
@@ -2402,7 +2681,7 @@
           </a:solidFill>
           <a:ln w="12700">
             <a:solidFill>
-              <a:srgbClr val="E6EEF5"/>
+              <a:srgbClr val="E1E5EB"/>
             </a:solidFill>
             <a:prstDash val="solid"/>
           </a:ln>
@@ -2410,143 +2689,24 @@
       </p:sp>
       <p:sp>
         <p:nvSpPr>
-          <p:cNvPr id="8" name="Text 6"/>
-          <p:cNvSpPr/>
-          <p:nvPr/>
-        </p:nvSpPr>
-        <p:spPr>
-          <a:xfrm>
-            <a:off x="4343400" y="2011680"/>
-            <a:ext cx="2286000" cy="731520"/>
-          </a:xfrm>
-          <a:prstGeom prst="rect">
-            <a:avLst/>
-          </a:prstGeom>
-          <a:noFill/>
-          <a:ln/>
-        </p:spPr>
-        <p:txBody>
-          <a:bodyPr wrap="square" lIns="0" tIns="0" rIns="0" bIns="0" rtlCol="0" anchor="ctr"/>
-          <a:lstStyle/>
-          <a:p>
-            <a:pPr algn="ctr" indent="0" marL="0">
-              <a:buNone/>
-            </a:pPr>
-            <a:r>
-              <a:rPr lang="en-US" sz="3600" b="1" dirty="0">
-                <a:solidFill>
-                  <a:srgbClr val="D91023"/>
-                </a:solidFill>
-                <a:latin typeface="Calibri" pitchFamily="34" charset="0"/>
-                <a:ea typeface="Calibri" pitchFamily="34" charset="-122"/>
-                <a:cs typeface="Calibri" pitchFamily="34" charset="-120"/>
-              </a:rPr>
-              <a:t>1</a:t>
-            </a:r>
-            <a:endParaRPr lang="en-US" sz="3600" dirty="0"/>
-          </a:p>
-        </p:txBody>
-      </p:sp>
-      <p:sp>
-        <p:nvSpPr>
-          <p:cNvPr id="9" name="Text 7"/>
-          <p:cNvSpPr/>
-          <p:nvPr/>
-        </p:nvSpPr>
-        <p:spPr>
-          <a:xfrm>
-            <a:off x="4343400" y="2926080"/>
-            <a:ext cx="2286000" cy="731520"/>
-          </a:xfrm>
-          <a:prstGeom prst="rect">
-            <a:avLst/>
-          </a:prstGeom>
-          <a:noFill/>
-          <a:ln/>
-        </p:spPr>
-        <p:txBody>
-          <a:bodyPr wrap="square" lIns="0" tIns="0" rIns="0" bIns="0" rtlCol="0" anchor="ctr"/>
-          <a:lstStyle/>
-          <a:p>
-            <a:pPr algn="ctr" indent="0" marL="0">
-              <a:buNone/>
-            </a:pPr>
-            <a:r>
-              <a:rPr lang="en-US" sz="2800" b="1" dirty="0">
-                <a:solidFill>
-                  <a:srgbClr val="003876"/>
-                </a:solidFill>
-                <a:latin typeface="Calibri" pitchFamily="34" charset="0"/>
-                <a:ea typeface="Calibri" pitchFamily="34" charset="-122"/>
-                <a:cs typeface="Calibri" pitchFamily="34" charset="-120"/>
-              </a:rPr>
-              <a:t>Trámites</a:t>
-            </a:r>
-            <a:endParaRPr lang="en-US" sz="2800" dirty="0"/>
-          </a:p>
-        </p:txBody>
-      </p:sp>
-      <p:sp>
-        <p:nvSpPr>
-          <p:cNvPr id="10" name="Text 8"/>
-          <p:cNvSpPr/>
-          <p:nvPr/>
-        </p:nvSpPr>
-        <p:spPr>
-          <a:xfrm>
-            <a:off x="4343400" y="3657600"/>
-            <a:ext cx="2286000" cy="914400"/>
-          </a:xfrm>
-          <a:prstGeom prst="rect">
-            <a:avLst/>
-          </a:prstGeom>
-          <a:noFill/>
-          <a:ln/>
-        </p:spPr>
-        <p:txBody>
-          <a:bodyPr wrap="square" lIns="1270" tIns="1270" rIns="1270" bIns="1270" rtlCol="0" anchor="ctr"/>
-          <a:lstStyle/>
-          <a:p>
-            <a:pPr algn="ctr" indent="0" marL="0">
-              <a:buNone/>
-            </a:pPr>
-            <a:r>
-              <a:rPr lang="en-US" sz="2000" dirty="0">
-                <a:solidFill>
-                  <a:srgbClr val="5A6578"/>
-                </a:solidFill>
-                <a:latin typeface="Calibri" pitchFamily="34" charset="0"/>
-                <a:ea typeface="Calibri" pitchFamily="34" charset="-122"/>
-                <a:cs typeface="Calibri" pitchFamily="34" charset="-120"/>
-              </a:rPr>
-              <a:t>ágiles</a:t>
-            </a:r>
-            <a:endParaRPr lang="en-US" sz="2000" dirty="0"/>
-          </a:p>
-        </p:txBody>
-      </p:sp>
-      <p:sp>
-        <p:nvSpPr>
-          <p:cNvPr id="11" name="Shape 9"/>
-          <p:cNvSpPr/>
-          <p:nvPr/>
-        </p:nvSpPr>
-        <p:spPr>
-          <a:xfrm>
-            <a:off x="6812280" y="1828800"/>
-            <a:ext cx="2286000" cy="3291840"/>
-          </a:xfrm>
-          <a:prstGeom prst="roundRect">
-            <a:avLst>
-              <a:gd name="adj" fmla="val 8000"/>
-            </a:avLst>
+          <p:cNvPr id="18" name="Shape 14"/>
+          <p:cNvSpPr/>
+          <p:nvPr/>
+        </p:nvSpPr>
+        <p:spPr>
+          <a:xfrm>
+            <a:off x="5852160" y="4983480"/>
+            <a:ext cx="640080" cy="640080"/>
+          </a:xfrm>
+          <a:prstGeom prst="ellipse">
+            <a:avLst/>
           </a:prstGeom>
           <a:solidFill>
-            <a:srgbClr val="E6EEF5"/>
+            <a:srgbClr val="003876"/>
           </a:solidFill>
           <a:ln w="12700">
             <a:solidFill>
-              <a:srgbClr val="E6EEF5"/>
+              <a:srgbClr val="003876"/>
             </a:solidFill>
             <a:prstDash val="solid"/>
           </a:ln>
@@ -2554,14 +2714,14 @@
       </p:sp>
       <p:sp>
         <p:nvSpPr>
-          <p:cNvPr id="12" name="Text 10"/>
-          <p:cNvSpPr/>
-          <p:nvPr/>
-        </p:nvSpPr>
-        <p:spPr>
-          <a:xfrm>
-            <a:off x="6812280" y="2011680"/>
-            <a:ext cx="2286000" cy="731520"/>
+          <p:cNvPr id="19" name="Text 15"/>
+          <p:cNvSpPr/>
+          <p:nvPr/>
+        </p:nvSpPr>
+        <p:spPr>
+          <a:xfrm>
+            <a:off x="5852160" y="4983480"/>
+            <a:ext cx="640080" cy="640080"/>
           </a:xfrm>
           <a:prstGeom prst="rect">
             <a:avLst/>
@@ -2577,85 +2737,85 @@
               <a:buNone/>
             </a:pPr>
             <a:r>
-              <a:rPr lang="en-US" sz="3600" b="1" dirty="0">
-                <a:solidFill>
-                  <a:srgbClr val="D91023"/>
-                </a:solidFill>
-                <a:latin typeface="Calibri" pitchFamily="34" charset="0"/>
-                <a:ea typeface="Calibri" pitchFamily="34" charset="-122"/>
-                <a:cs typeface="Calibri" pitchFamily="34" charset="-120"/>
-              </a:rPr>
-              <a:t>2</a:t>
-            </a:r>
-            <a:endParaRPr lang="en-US" sz="3600" dirty="0"/>
-          </a:p>
-        </p:txBody>
-      </p:sp>
-      <p:sp>
-        <p:nvSpPr>
-          <p:cNvPr id="13" name="Text 11"/>
-          <p:cNvSpPr/>
-          <p:nvPr/>
-        </p:nvSpPr>
-        <p:spPr>
-          <a:xfrm>
-            <a:off x="6812280" y="2926080"/>
-            <a:ext cx="2286000" cy="731520"/>
-          </a:xfrm>
-          <a:prstGeom prst="rect">
-            <a:avLst/>
-          </a:prstGeom>
-          <a:noFill/>
-          <a:ln/>
-        </p:spPr>
-        <p:txBody>
-          <a:bodyPr wrap="square" lIns="0" tIns="0" rIns="0" bIns="0" rtlCol="0" anchor="ctr"/>
-          <a:lstStyle/>
-          <a:p>
-            <a:pPr algn="ctr" indent="0" marL="0">
-              <a:buNone/>
-            </a:pPr>
-            <a:r>
-              <a:rPr lang="en-US" sz="2800" b="1" dirty="0">
-                <a:solidFill>
-                  <a:srgbClr val="003876"/>
-                </a:solidFill>
-                <a:latin typeface="Calibri" pitchFamily="34" charset="0"/>
-                <a:ea typeface="Calibri" pitchFamily="34" charset="-122"/>
-                <a:cs typeface="Calibri" pitchFamily="34" charset="-120"/>
-              </a:rPr>
-              <a:t>Bitácora</a:t>
-            </a:r>
-            <a:endParaRPr lang="en-US" sz="2800" dirty="0"/>
-          </a:p>
-        </p:txBody>
-      </p:sp>
-      <p:sp>
-        <p:nvSpPr>
-          <p:cNvPr id="14" name="Text 12"/>
-          <p:cNvSpPr/>
-          <p:nvPr/>
-        </p:nvSpPr>
-        <p:spPr>
-          <a:xfrm>
-            <a:off x="6812280" y="3657600"/>
-            <a:ext cx="2286000" cy="914400"/>
-          </a:xfrm>
-          <a:prstGeom prst="rect">
-            <a:avLst/>
-          </a:prstGeom>
-          <a:noFill/>
-          <a:ln/>
-        </p:spPr>
-        <p:txBody>
-          <a:bodyPr wrap="square" lIns="1270" tIns="1270" rIns="1270" bIns="1270" rtlCol="0" anchor="ctr"/>
-          <a:lstStyle/>
-          <a:p>
-            <a:pPr algn="ctr" indent="0" marL="0">
-              <a:buNone/>
-            </a:pPr>
-            <a:r>
-              <a:rPr lang="en-US" sz="2000" dirty="0">
+              <a:rPr lang="en-US" sz="2400" b="1" dirty="0">
+                <a:solidFill>
+                  <a:srgbClr val="FFFFFF"/>
+                </a:solidFill>
+                <a:latin typeface="Calibri" pitchFamily="34" charset="0"/>
+                <a:ea typeface="Calibri" pitchFamily="34" charset="-122"/>
+                <a:cs typeface="Calibri" pitchFamily="34" charset="-120"/>
+              </a:rPr>
+              <a:t>3</a:t>
+            </a:r>
+            <a:endParaRPr lang="en-US" sz="2400" dirty="0"/>
+          </a:p>
+        </p:txBody>
+      </p:sp>
+      <p:sp>
+        <p:nvSpPr>
+          <p:cNvPr id="20" name="Text 16"/>
+          <p:cNvSpPr/>
+          <p:nvPr/>
+        </p:nvSpPr>
+        <p:spPr>
+          <a:xfrm>
+            <a:off x="6720840" y="4754880"/>
+            <a:ext cx="4663440" cy="502920"/>
+          </a:xfrm>
+          <a:prstGeom prst="rect">
+            <a:avLst/>
+          </a:prstGeom>
+          <a:noFill/>
+          <a:ln/>
+        </p:spPr>
+        <p:txBody>
+          <a:bodyPr wrap="square" lIns="0" tIns="0" rIns="0" bIns="0" rtlCol="0" anchor="ctr"/>
+          <a:lstStyle/>
+          <a:p>
+            <a:pPr indent="0" marL="0">
+              <a:buNone/>
+            </a:pPr>
+            <a:r>
+              <a:rPr lang="en-US" sz="2600" b="1" dirty="0">
+                <a:solidFill>
+                  <a:srgbClr val="1A2332"/>
+                </a:solidFill>
+                <a:latin typeface="Calibri" pitchFamily="34" charset="0"/>
+                <a:ea typeface="Calibri" pitchFamily="34" charset="-122"/>
+                <a:cs typeface="Calibri" pitchFamily="34" charset="-120"/>
+              </a:rPr>
+              <a:t>Cero papeleo extra</a:t>
+            </a:r>
+            <a:endParaRPr lang="en-US" sz="2600" dirty="0"/>
+          </a:p>
+        </p:txBody>
+      </p:sp>
+      <p:sp>
+        <p:nvSpPr>
+          <p:cNvPr id="21" name="Text 17"/>
+          <p:cNvSpPr/>
+          <p:nvPr/>
+        </p:nvSpPr>
+        <p:spPr>
+          <a:xfrm>
+            <a:off x="6720840" y="5285232"/>
+            <a:ext cx="4663440" cy="594360"/>
+          </a:xfrm>
+          <a:prstGeom prst="rect">
+            <a:avLst/>
+          </a:prstGeom>
+          <a:noFill/>
+          <a:ln/>
+        </p:spPr>
+        <p:txBody>
+          <a:bodyPr wrap="square" lIns="0" tIns="0" rIns="0" bIns="0" rtlCol="0" anchor="ctr"/>
+          <a:lstStyle/>
+          <a:p>
+            <a:pPr indent="0" marL="0">
+              <a:buNone/>
+            </a:pPr>
+            <a:r>
+              <a:rPr lang="en-US" sz="1800" dirty="0">
                 <a:solidFill>
                   <a:srgbClr val="5A6578"/>
                 </a:solidFill>
@@ -2663,204 +2823,21 @@
                 <a:ea typeface="Calibri" pitchFamily="34" charset="-122"/>
                 <a:cs typeface="Calibri" pitchFamily="34" charset="-120"/>
               </a:rPr>
-              <a:t>de observaciones</a:t>
-            </a:r>
-            <a:endParaRPr lang="en-US" sz="2000" dirty="0"/>
-          </a:p>
-        </p:txBody>
-      </p:sp>
-      <p:sp>
-        <p:nvSpPr>
-          <p:cNvPr id="15" name="Shape 13"/>
-          <p:cNvSpPr/>
-          <p:nvPr/>
-        </p:nvSpPr>
-        <p:spPr>
-          <a:xfrm>
-            <a:off x="9281160" y="1828800"/>
-            <a:ext cx="2286000" cy="3291840"/>
-          </a:xfrm>
-          <a:prstGeom prst="roundRect">
-            <a:avLst>
-              <a:gd name="adj" fmla="val 8000"/>
-            </a:avLst>
-          </a:prstGeom>
-          <a:solidFill>
-            <a:srgbClr val="E6EEF5"/>
-          </a:solidFill>
-          <a:ln w="12700">
-            <a:solidFill>
-              <a:srgbClr val="E6EEF5"/>
-            </a:solidFill>
-            <a:prstDash val="solid"/>
-          </a:ln>
-        </p:spPr>
-      </p:sp>
-      <p:sp>
-        <p:nvSpPr>
-          <p:cNvPr id="16" name="Text 14"/>
-          <p:cNvSpPr/>
-          <p:nvPr/>
-        </p:nvSpPr>
-        <p:spPr>
-          <a:xfrm>
-            <a:off x="9281160" y="2011680"/>
-            <a:ext cx="2286000" cy="731520"/>
-          </a:xfrm>
-          <a:prstGeom prst="rect">
-            <a:avLst/>
-          </a:prstGeom>
-          <a:noFill/>
-          <a:ln/>
-        </p:spPr>
-        <p:txBody>
-          <a:bodyPr wrap="square" lIns="0" tIns="0" rIns="0" bIns="0" rtlCol="0" anchor="ctr"/>
-          <a:lstStyle/>
-          <a:p>
-            <a:pPr algn="ctr" indent="0" marL="0">
-              <a:buNone/>
-            </a:pPr>
-            <a:r>
-              <a:rPr lang="en-US" sz="3600" b="1" dirty="0">
-                <a:solidFill>
-                  <a:srgbClr val="D91023"/>
-                </a:solidFill>
-                <a:latin typeface="Calibri" pitchFamily="34" charset="0"/>
-                <a:ea typeface="Calibri" pitchFamily="34" charset="-122"/>
-                <a:cs typeface="Calibri" pitchFamily="34" charset="-120"/>
-              </a:rPr>
-              <a:t>3</a:t>
-            </a:r>
-            <a:endParaRPr lang="en-US" sz="3600" dirty="0"/>
-          </a:p>
-        </p:txBody>
-      </p:sp>
-      <p:sp>
-        <p:nvSpPr>
-          <p:cNvPr id="17" name="Text 15"/>
-          <p:cNvSpPr/>
-          <p:nvPr/>
-        </p:nvSpPr>
-        <p:spPr>
-          <a:xfrm>
-            <a:off x="9281160" y="2926080"/>
-            <a:ext cx="2286000" cy="731520"/>
-          </a:xfrm>
-          <a:prstGeom prst="rect">
-            <a:avLst/>
-          </a:prstGeom>
-          <a:noFill/>
-          <a:ln/>
-        </p:spPr>
-        <p:txBody>
-          <a:bodyPr wrap="square" lIns="0" tIns="0" rIns="0" bIns="0" rtlCol="0" anchor="ctr"/>
-          <a:lstStyle/>
-          <a:p>
-            <a:pPr algn="ctr" indent="0" marL="0">
-              <a:buNone/>
-            </a:pPr>
-            <a:r>
-              <a:rPr lang="en-US" sz="2800" b="1" dirty="0">
-                <a:solidFill>
-                  <a:srgbClr val="003876"/>
-                </a:solidFill>
-                <a:latin typeface="Calibri" pitchFamily="34" charset="0"/>
-                <a:ea typeface="Calibri" pitchFamily="34" charset="-122"/>
-                <a:cs typeface="Calibri" pitchFamily="34" charset="-120"/>
-              </a:rPr>
-              <a:t>Alertas</a:t>
-            </a:r>
-            <a:endParaRPr lang="en-US" sz="2800" dirty="0"/>
-          </a:p>
-        </p:txBody>
-      </p:sp>
-      <p:sp>
-        <p:nvSpPr>
-          <p:cNvPr id="18" name="Text 16"/>
-          <p:cNvSpPr/>
-          <p:nvPr/>
-        </p:nvSpPr>
-        <p:spPr>
-          <a:xfrm>
-            <a:off x="9281160" y="3657600"/>
-            <a:ext cx="2286000" cy="914400"/>
-          </a:xfrm>
-          <a:prstGeom prst="rect">
-            <a:avLst/>
-          </a:prstGeom>
-          <a:noFill/>
-          <a:ln/>
-        </p:spPr>
-        <p:txBody>
-          <a:bodyPr wrap="square" lIns="1270" tIns="1270" rIns="1270" bIns="1270" rtlCol="0" anchor="ctr"/>
-          <a:lstStyle/>
-          <a:p>
-            <a:pPr algn="ctr" indent="0" marL="0">
-              <a:buNone/>
-            </a:pPr>
-            <a:r>
-              <a:rPr lang="en-US" sz="2000" dirty="0">
-                <a:solidFill>
-                  <a:srgbClr val="5A6578"/>
-                </a:solidFill>
-                <a:latin typeface="Calibri" pitchFamily="34" charset="0"/>
-                <a:ea typeface="Calibri" pitchFamily="34" charset="-122"/>
-                <a:cs typeface="Calibri" pitchFamily="34" charset="-120"/>
-              </a:rPr>
-              <a:t>alumnos en riesgo</a:t>
-            </a:r>
-            <a:endParaRPr lang="en-US" sz="2000" dirty="0"/>
-          </a:p>
-        </p:txBody>
-      </p:sp>
-      <p:sp>
-        <p:nvSpPr>
-          <p:cNvPr id="19" name="Text 17"/>
-          <p:cNvSpPr/>
-          <p:nvPr/>
-        </p:nvSpPr>
-        <p:spPr>
-          <a:xfrm>
-            <a:off x="548640" y="5577840"/>
-            <a:ext cx="10972800" cy="548640"/>
-          </a:xfrm>
-          <a:prstGeom prst="rect">
-            <a:avLst/>
-          </a:prstGeom>
-          <a:noFill/>
-          <a:ln/>
-        </p:spPr>
-        <p:txBody>
-          <a:bodyPr wrap="square" lIns="0" tIns="0" rIns="0" bIns="0" rtlCol="0" anchor="ctr"/>
-          <a:lstStyle/>
-          <a:p>
-            <a:pPr indent="0" marL="0">
-              <a:buNone/>
-            </a:pPr>
-            <a:r>
-              <a:rPr lang="en-US" sz="2400" b="1" dirty="0">
-                <a:solidFill>
-                  <a:srgbClr val="1A2332"/>
-                </a:solidFill>
-                <a:latin typeface="Calibri" pitchFamily="34" charset="0"/>
-                <a:ea typeface="Calibri" pitchFamily="34" charset="-122"/>
-                <a:cs typeface="Calibri" pitchFamily="34" charset="-120"/>
-              </a:rPr>
-              <a:t>Director · UGEL · Ministerio sincronizados en tiempo real</a:t>
-            </a:r>
-            <a:endParaRPr lang="en-US" sz="2400" dirty="0"/>
-          </a:p>
-        </p:txBody>
-      </p:sp>
-      <p:sp>
-        <p:nvSpPr>
-          <p:cNvPr id="20" name="Text 18"/>
-          <p:cNvSpPr/>
-          <p:nvPr/>
-        </p:nvSpPr>
-        <p:spPr>
-          <a:xfrm>
-            <a:off x="548640" y="6309360"/>
+              <a:t>Director, UGEL y MINEDU sincronizados en tiempo real</a:t>
+            </a:r>
+            <a:endParaRPr lang="en-US" sz="1800" dirty="0"/>
+          </a:p>
+        </p:txBody>
+      </p:sp>
+      <p:sp>
+        <p:nvSpPr>
+          <p:cNvPr id="22" name="Text 18"/>
+          <p:cNvSpPr/>
+          <p:nvPr/>
+        </p:nvSpPr>
+        <p:spPr>
+          <a:xfrm>
+            <a:off x="548640" y="6355080"/>
             <a:ext cx="5486400" cy="320040"/>
           </a:xfrm>
           <a:prstGeom prst="rect">
@@ -3244,7 +3221,7 @@
                 <a:ea typeface="Calibri" pitchFamily="34" charset="-122"/>
                 <a:cs typeface="Calibri" pitchFamily="34" charset="-120"/>
               </a:rPr>
-              <a:t>Caso</a:t>
+              <a:t>Caso Nayeli</a:t>
             </a:r>
             <a:endParaRPr lang="en-US" sz="3000" dirty="0"/>
           </a:p>
@@ -4286,7 +4263,7 @@
         </p:nvSpPr>
         <p:spPr>
           <a:xfrm>
-            <a:off x="548640" y="6309360"/>
+            <a:off x="548640" y="6355080"/>
             <a:ext cx="5486400" cy="320040"/>
           </a:xfrm>
           <a:prstGeom prst="rect">

</xml_diff>